<commit_message>
Generate the DeLong table instead of quoting it; add its producer script
The audit caught section 24.1 and deck slide 9 carrying DeLong numbers that no
longer reproduced from outputs/scores__consent__matched.parquet: gbm vs tabpfn was
given as -0.0026 (p 0.691) against the artifact's -0.0051 (p 0.413), scorecard vs
gbm as -0.0173 (p 0.019) against -0.0149 (p 0.032), and the table carried a
decision-tree arm that is not in the matched scores at all. They came from an
interactive run.

scripts/run_significance.py now recomputes them and writes
outputs/significance__consent__matched.json; the slide builds its rows from that
file, and section 24.1 prints the marginal AUCs so they can be checked against
metrics__consent__matched.json at a glance. The conclusion is unchanged - the two
black boxes are indistinguishable, the scorecard is significantly worse than both -
but the figures now tie out and section 24 is no longer unreproducible.
</commit_message>
<xml_diff>
--- a/reports/ISAF_presentation.pptx
+++ b/reports/ISAF_presentation.pptx
@@ -16513,7 +16513,7 @@
         </p:nvGraphicFramePr>
         <p:xfrm>
           <a:off x="658368" y="1737360"/>
-          <a:ext cx="10874956" cy="1865376"/>
+          <a:ext cx="10874956" cy="1243584"/>
         </p:xfrm>
         <a:graphic>
           <a:graphicData uri="http://schemas.openxmlformats.org/drawingml/2006/table">
@@ -16522,11 +16522,12 @@
                 <a:tableStyleId>{5C22544A-7EE6-4342-B048-85BDC9FD1C3A}</a:tableStyleId>
               </a:tblPr>
               <a:tblGrid>
-                <a:gridCol w="3434197"/>
-                <a:gridCol w="1488152"/>
-                <a:gridCol w="2632884"/>
-                <a:gridCol w="1144732"/>
-                <a:gridCol w="2174991"/>
+                <a:gridCol w="3346141"/>
+                <a:gridCol w="1314555"/>
+                <a:gridCol w="1314555"/>
+                <a:gridCol w="1434060"/>
+                <a:gridCol w="1195050"/>
+                <a:gridCol w="2270595"/>
               </a:tblGrid>
               <a:tr h="310896">
                 <a:tc>
@@ -16565,30 +16566,53 @@
                           </a:solidFill>
                           <a:latin typeface="Arial"/>
                         </a:rPr>
+                        <a:t>AUC a</a:t>
+                      </a:r>
+                    </a:p>
+                  </a:txBody>
+                  <a:tcPr anchor="ctr">
+                    <a:solidFill>
+                      <a:srgbClr val="1A1A2E"/>
+                    </a:solidFill>
+                  </a:tcPr>
+                </a:tc>
+                <a:tc>
+                  <a:txBody>
+                    <a:bodyPr/>
+                    <a:lstStyle/>
+                    <a:p>
+                      <a:pPr algn="ctr"/>
+                      <a:r>
+                        <a:rPr sz="1150" b="1" i="0">
+                          <a:solidFill>
+                            <a:srgbClr val="FFFFFF"/>
+                          </a:solidFill>
+                          <a:latin typeface="Arial"/>
+                        </a:rPr>
+                        <a:t>AUC b</a:t>
+                      </a:r>
+                    </a:p>
+                  </a:txBody>
+                  <a:tcPr anchor="ctr">
+                    <a:solidFill>
+                      <a:srgbClr val="1A1A2E"/>
+                    </a:solidFill>
+                  </a:tcPr>
+                </a:tc>
+                <a:tc>
+                  <a:txBody>
+                    <a:bodyPr/>
+                    <a:lstStyle/>
+                    <a:p>
+                      <a:pPr algn="ctr"/>
+                      <a:r>
+                        <a:rPr sz="1150" b="1" i="0">
+                          <a:solidFill>
+                            <a:srgbClr val="FFFFFF"/>
+                          </a:solidFill>
+                          <a:latin typeface="Arial"/>
+                        </a:rPr>
                         <a:t>Δ AUC</a:t>
-                      </a:r>
-                    </a:p>
-                  </a:txBody>
-                  <a:tcPr anchor="ctr">
-                    <a:solidFill>
-                      <a:srgbClr val="1A1A2E"/>
-                    </a:solidFill>
-                  </a:tcPr>
-                </a:tc>
-                <a:tc>
-                  <a:txBody>
-                    <a:bodyPr/>
-                    <a:lstStyle/>
-                    <a:p>
-                      <a:pPr algn="ctr"/>
-                      <a:r>
-                        <a:rPr sz="1150" b="1" i="0">
-                          <a:solidFill>
-                            <a:srgbClr val="FFFFFF"/>
-                          </a:solidFill>
-                          <a:latin typeface="Arial"/>
-                        </a:rPr>
-                        <a:t>95% CI</a:t>
                       </a:r>
                     </a:p>
                   </a:txBody>
@@ -16659,7 +16683,7 @@
                           </a:solidFill>
                           <a:latin typeface="Arial"/>
                         </a:rPr>
-                        <a:t>XGBoost vs TabPFN</a:t>
+                        <a:t>Scorecard vs XGBoost</a:t>
                       </a:r>
                     </a:p>
                   </a:txBody>
@@ -16682,7 +16706,7 @@
                           </a:solidFill>
                           <a:latin typeface="Arial"/>
                         </a:rPr>
-                        <a:t>−0.0026</a:t>
+                        <a:t>0.5329</a:t>
                       </a:r>
                     </a:p>
                   </a:txBody>
@@ -16705,7 +16729,7 @@
                           </a:solidFill>
                           <a:latin typeface="Arial"/>
                         </a:rPr>
-                        <a:t>[−0.0157, +0.0104]</a:t>
+                        <a:t>0.5478</a:t>
                       </a:r>
                     </a:p>
                   </a:txBody>
@@ -16728,7 +16752,7 @@
                           </a:solidFill>
                           <a:latin typeface="Arial"/>
                         </a:rPr>
-                        <a:t>0.691</a:t>
+                        <a:t>−0.0149</a:t>
                       </a:r>
                     </a:p>
                   </a:txBody>
@@ -16751,7 +16775,30 @@
                           </a:solidFill>
                           <a:latin typeface="Arial"/>
                         </a:rPr>
-                        <a:t>not significant</a:t>
+                        <a:t>0.032</a:t>
+                      </a:r>
+                    </a:p>
+                  </a:txBody>
+                  <a:tcPr anchor="ctr">
+                    <a:solidFill>
+                      <a:srgbClr val="FFFFFF"/>
+                    </a:solidFill>
+                  </a:tcPr>
+                </a:tc>
+                <a:tc>
+                  <a:txBody>
+                    <a:bodyPr/>
+                    <a:lstStyle/>
+                    <a:p>
+                      <a:pPr algn="ctr"/>
+                      <a:r>
+                        <a:rPr sz="1150" b="1" i="0">
+                          <a:solidFill>
+                            <a:srgbClr val="C0392B"/>
+                          </a:solidFill>
+                          <a:latin typeface="Arial"/>
+                        </a:rPr>
+                        <a:t>SIGNIFICANT</a:t>
                       </a:r>
                     </a:p>
                   </a:txBody>
@@ -16776,7 +16823,7 @@
                           </a:solidFill>
                           <a:latin typeface="Arial"/>
                         </a:rPr>
-                        <a:t>XGBoost vs tree</a:t>
+                        <a:t>Scorecard vs TabPFN</a:t>
                       </a:r>
                     </a:p>
                   </a:txBody>
@@ -16799,7 +16846,7 @@
                           </a:solidFill>
                           <a:latin typeface="Arial"/>
                         </a:rPr>
-                        <a:t>+0.0062</a:t>
+                        <a:t>0.5329</a:t>
                       </a:r>
                     </a:p>
                   </a:txBody>
@@ -16822,7 +16869,7 @@
                           </a:solidFill>
                           <a:latin typeface="Arial"/>
                         </a:rPr>
-                        <a:t>[−0.0091, +0.0215]</a:t>
+                        <a:t>0.5529</a:t>
                       </a:r>
                     </a:p>
                   </a:txBody>
@@ -16845,7 +16892,7 @@
                           </a:solidFill>
                           <a:latin typeface="Arial"/>
                         </a:rPr>
-                        <a:t>0.431</a:t>
+                        <a:t>−0.0200</a:t>
                       </a:r>
                     </a:p>
                   </a:txBody>
@@ -16868,7 +16915,30 @@
                           </a:solidFill>
                           <a:latin typeface="Arial"/>
                         </a:rPr>
-                        <a:t>not significant</a:t>
+                        <a:t>&lt;0.001</a:t>
+                      </a:r>
+                    </a:p>
+                  </a:txBody>
+                  <a:tcPr anchor="ctr">
+                    <a:solidFill>
+                      <a:srgbClr val="F2F1EE"/>
+                    </a:solidFill>
+                  </a:tcPr>
+                </a:tc>
+                <a:tc>
+                  <a:txBody>
+                    <a:bodyPr/>
+                    <a:lstStyle/>
+                    <a:p>
+                      <a:pPr algn="ctr"/>
+                      <a:r>
+                        <a:rPr sz="1150" b="1" i="0">
+                          <a:solidFill>
+                            <a:srgbClr val="C0392B"/>
+                          </a:solidFill>
+                          <a:latin typeface="Arial"/>
+                        </a:rPr>
+                        <a:t>SIGNIFICANT</a:t>
                       </a:r>
                     </a:p>
                   </a:txBody>
@@ -16893,7 +16963,7 @@
                           </a:solidFill>
                           <a:latin typeface="Arial"/>
                         </a:rPr>
-                        <a:t>Tree vs TabPFN</a:t>
+                        <a:t>XGBoost vs TabPFN</a:t>
                       </a:r>
                     </a:p>
                   </a:txBody>
@@ -16916,7 +16986,7 @@
                           </a:solidFill>
                           <a:latin typeface="Arial"/>
                         </a:rPr>
-                        <a:t>−0.0088</a:t>
+                        <a:t>0.5478</a:t>
                       </a:r>
                     </a:p>
                   </a:txBody>
@@ -16939,7 +17009,7 @@
                           </a:solidFill>
                           <a:latin typeface="Arial"/>
                         </a:rPr>
-                        <a:t>[−0.0212, +0.0036]</a:t>
+                        <a:t>0.5529</a:t>
                       </a:r>
                     </a:p>
                   </a:txBody>
@@ -16962,7 +17032,7 @@
                           </a:solidFill>
                           <a:latin typeface="Arial"/>
                         </a:rPr>
-                        <a:t>0.163</a:t>
+                        <a:t>−0.0051</a:t>
                       </a:r>
                     </a:p>
                   </a:txBody>
@@ -16985,241 +17055,30 @@
                           </a:solidFill>
                           <a:latin typeface="Arial"/>
                         </a:rPr>
+                        <a:t>0.413</a:t>
+                      </a:r>
+                    </a:p>
+                  </a:txBody>
+                  <a:tcPr anchor="ctr">
+                    <a:solidFill>
+                      <a:srgbClr val="FFFFFF"/>
+                    </a:solidFill>
+                  </a:tcPr>
+                </a:tc>
+                <a:tc>
+                  <a:txBody>
+                    <a:bodyPr/>
+                    <a:lstStyle/>
+                    <a:p>
+                      <a:pPr algn="ctr"/>
+                      <a:r>
+                        <a:rPr sz="1150" b="0" i="0">
+                          <a:solidFill>
+                            <a:srgbClr val="1A1A2E"/>
+                          </a:solidFill>
+                          <a:latin typeface="Arial"/>
+                        </a:rPr>
                         <a:t>not significant</a:t>
-                      </a:r>
-                    </a:p>
-                  </a:txBody>
-                  <a:tcPr anchor="ctr">
-                    <a:solidFill>
-                      <a:srgbClr val="FFFFFF"/>
-                    </a:solidFill>
-                  </a:tcPr>
-                </a:tc>
-              </a:tr>
-              <a:tr h="310896">
-                <a:tc>
-                  <a:txBody>
-                    <a:bodyPr/>
-                    <a:lstStyle/>
-                    <a:p>
-                      <a:pPr algn="l"/>
-                      <a:r>
-                        <a:rPr sz="1150" b="1" i="0">
-                          <a:solidFill>
-                            <a:srgbClr val="1A1A2E"/>
-                          </a:solidFill>
-                          <a:latin typeface="Arial"/>
-                        </a:rPr>
-                        <a:t>Scorecard vs XGBoost</a:t>
-                      </a:r>
-                    </a:p>
-                  </a:txBody>
-                  <a:tcPr anchor="ctr">
-                    <a:solidFill>
-                      <a:srgbClr val="F2F1EE"/>
-                    </a:solidFill>
-                  </a:tcPr>
-                </a:tc>
-                <a:tc>
-                  <a:txBody>
-                    <a:bodyPr/>
-                    <a:lstStyle/>
-                    <a:p>
-                      <a:pPr algn="ctr"/>
-                      <a:r>
-                        <a:rPr sz="1150" b="0" i="0">
-                          <a:solidFill>
-                            <a:srgbClr val="1A1A2E"/>
-                          </a:solidFill>
-                          <a:latin typeface="Arial"/>
-                        </a:rPr>
-                        <a:t>−0.0173</a:t>
-                      </a:r>
-                    </a:p>
-                  </a:txBody>
-                  <a:tcPr anchor="ctr">
-                    <a:solidFill>
-                      <a:srgbClr val="F2F1EE"/>
-                    </a:solidFill>
-                  </a:tcPr>
-                </a:tc>
-                <a:tc>
-                  <a:txBody>
-                    <a:bodyPr/>
-                    <a:lstStyle/>
-                    <a:p>
-                      <a:pPr algn="ctr"/>
-                      <a:r>
-                        <a:rPr sz="1150" b="0" i="0">
-                          <a:solidFill>
-                            <a:srgbClr val="1A1A2E"/>
-                          </a:solidFill>
-                          <a:latin typeface="Arial"/>
-                        </a:rPr>
-                        <a:t>[−0.0317, −0.0028]</a:t>
-                      </a:r>
-                    </a:p>
-                  </a:txBody>
-                  <a:tcPr anchor="ctr">
-                    <a:solidFill>
-                      <a:srgbClr val="F2F1EE"/>
-                    </a:solidFill>
-                  </a:tcPr>
-                </a:tc>
-                <a:tc>
-                  <a:txBody>
-                    <a:bodyPr/>
-                    <a:lstStyle/>
-                    <a:p>
-                      <a:pPr algn="ctr"/>
-                      <a:r>
-                        <a:rPr sz="1150" b="0" i="0">
-                          <a:solidFill>
-                            <a:srgbClr val="1A1A2E"/>
-                          </a:solidFill>
-                          <a:latin typeface="Arial"/>
-                        </a:rPr>
-                        <a:t>0.019</a:t>
-                      </a:r>
-                    </a:p>
-                  </a:txBody>
-                  <a:tcPr anchor="ctr">
-                    <a:solidFill>
-                      <a:srgbClr val="F2F1EE"/>
-                    </a:solidFill>
-                  </a:tcPr>
-                </a:tc>
-                <a:tc>
-                  <a:txBody>
-                    <a:bodyPr/>
-                    <a:lstStyle/>
-                    <a:p>
-                      <a:pPr algn="ctr"/>
-                      <a:r>
-                        <a:rPr sz="1150" b="1" i="0">
-                          <a:solidFill>
-                            <a:srgbClr val="C0392B"/>
-                          </a:solidFill>
-                          <a:latin typeface="Arial"/>
-                        </a:rPr>
-                        <a:t>SIGNIFICANT</a:t>
-                      </a:r>
-                    </a:p>
-                  </a:txBody>
-                  <a:tcPr anchor="ctr">
-                    <a:solidFill>
-                      <a:srgbClr val="F2F1EE"/>
-                    </a:solidFill>
-                  </a:tcPr>
-                </a:tc>
-              </a:tr>
-              <a:tr h="310896">
-                <a:tc>
-                  <a:txBody>
-                    <a:bodyPr/>
-                    <a:lstStyle/>
-                    <a:p>
-                      <a:pPr algn="l"/>
-                      <a:r>
-                        <a:rPr sz="1150" b="1" i="0">
-                          <a:solidFill>
-                            <a:srgbClr val="1A1A2E"/>
-                          </a:solidFill>
-                          <a:latin typeface="Arial"/>
-                        </a:rPr>
-                        <a:t>Scorecard vs TabPFN</a:t>
-                      </a:r>
-                    </a:p>
-                  </a:txBody>
-                  <a:tcPr anchor="ctr">
-                    <a:solidFill>
-                      <a:srgbClr val="FFFFFF"/>
-                    </a:solidFill>
-                  </a:tcPr>
-                </a:tc>
-                <a:tc>
-                  <a:txBody>
-                    <a:bodyPr/>
-                    <a:lstStyle/>
-                    <a:p>
-                      <a:pPr algn="ctr"/>
-                      <a:r>
-                        <a:rPr sz="1150" b="0" i="0">
-                          <a:solidFill>
-                            <a:srgbClr val="1A1A2E"/>
-                          </a:solidFill>
-                          <a:latin typeface="Arial"/>
-                        </a:rPr>
-                        <a:t>−0.0199</a:t>
-                      </a:r>
-                    </a:p>
-                  </a:txBody>
-                  <a:tcPr anchor="ctr">
-                    <a:solidFill>
-                      <a:srgbClr val="FFFFFF"/>
-                    </a:solidFill>
-                  </a:tcPr>
-                </a:tc>
-                <a:tc>
-                  <a:txBody>
-                    <a:bodyPr/>
-                    <a:lstStyle/>
-                    <a:p>
-                      <a:pPr algn="ctr"/>
-                      <a:r>
-                        <a:rPr sz="1150" b="0" i="0">
-                          <a:solidFill>
-                            <a:srgbClr val="1A1A2E"/>
-                          </a:solidFill>
-                          <a:latin typeface="Arial"/>
-                        </a:rPr>
-                        <a:t>[−0.0291, −0.0108]</a:t>
-                      </a:r>
-                    </a:p>
-                  </a:txBody>
-                  <a:tcPr anchor="ctr">
-                    <a:solidFill>
-                      <a:srgbClr val="FFFFFF"/>
-                    </a:solidFill>
-                  </a:tcPr>
-                </a:tc>
-                <a:tc>
-                  <a:txBody>
-                    <a:bodyPr/>
-                    <a:lstStyle/>
-                    <a:p>
-                      <a:pPr algn="ctr"/>
-                      <a:r>
-                        <a:rPr sz="1150" b="0" i="0">
-                          <a:solidFill>
-                            <a:srgbClr val="1A1A2E"/>
-                          </a:solidFill>
-                          <a:latin typeface="Arial"/>
-                        </a:rPr>
-                        <a:t>&lt;0.001</a:t>
-                      </a:r>
-                    </a:p>
-                  </a:txBody>
-                  <a:tcPr anchor="ctr">
-                    <a:solidFill>
-                      <a:srgbClr val="FFFFFF"/>
-                    </a:solidFill>
-                  </a:tcPr>
-                </a:tc>
-                <a:tc>
-                  <a:txBody>
-                    <a:bodyPr/>
-                    <a:lstStyle/>
-                    <a:p>
-                      <a:pPr algn="ctr"/>
-                      <a:r>
-                        <a:rPr sz="1150" b="1" i="0">
-                          <a:solidFill>
-                            <a:srgbClr val="C0392B"/>
-                          </a:solidFill>
-                          <a:latin typeface="Arial"/>
-                        </a:rPr>
-                        <a:t>SIGNIFICANT</a:t>
                       </a:r>
                     </a:p>
                   </a:txBody>
@@ -17356,7 +17215,7 @@
                 </a:solidFill>
                 <a:latin typeface="Arial"/>
               </a:rPr>
-              <a:t>DeLong paired test on correlated AUCs. The two black boxes are statistically indistinguishable, so we do not rank them — any choice between them must be made on the other three dimensions.</a:t>
+              <a:t>DeLong paired test on correlated AUCs, recomputed from the cached scores by scripts/run_significance.py. The two black boxes are statistically indistinguishable, so we do not rank them — any choice between them must be made on the other three dimensions.</a:t>
             </a:r>
           </a:p>
         </p:txBody>

</xml_diff>